<commit_message>
feat: migrate AI pipeline to Google Gemini
</commit_message>
<xml_diff>
--- a/Projeto_Final_Artefatos/InsurMinds_Projeto_Final.pptx
+++ b/Projeto_Final_Artefatos/InsurMinds_Projeto_Final.pptx
@@ -773,7 +773,7 @@
           <a:p>
             <a:r>
               <a:rPr lang="en-US" dirty="0"/>
-              <a:t>Fluxo: interface, API, recepção, leitura por página, extração multimodal, validação de evidências, SQLite e comparação. Documentação: docs/ARQUITETURA.md. OpenAI Structured Outputs: https://developers.openai.com/api/docs/guides/structured-outputs</a:t>
+              <a:t>Fluxo: interface, API, recepção, leitura por página, extração multimodal, validação de evidências, SQLite e comparação. Documentação: docs/ARQUITETURA.md. Gemini structured output: https://ai.google.dev/gemini-api/docs/structured-output</a:t>
             </a:r>
             <a:endParaRPr lang="en-US" dirty="0"/>
           </a:p>
@@ -2699,7 +2699,7 @@
                 <a:ea typeface="Aptos" pitchFamily="34" charset="-122"/>
                 <a:cs typeface="Aptos" pitchFamily="34" charset="-120"/>
               </a:rPr>
-              <a:t>OpenAI + Pydantic</a:t>
+              <a:t>Gemini + Pydantic</a:t>
             </a:r>
             <a:endParaRPr lang="en-US" sz="2400" dirty="0"/>
           </a:p>

</xml_diff>

<commit_message>
docs(delivery): refresh project docs and artifacts
</commit_message>
<xml_diff>
--- a/Projeto_Final_Artefatos/InsurMinds_Projeto_Final.pptx
+++ b/Projeto_Final_Artefatos/InsurMinds_Projeto_Final.pptx
@@ -509,7 +509,7 @@
           <a:p>
             <a:r>
               <a:rPr lang="en-US" dirty="0"/>
-              <a:t>Enunciado do Projeto Final I2A2, fornecido pelo usuário, datado de 15/07/2026. Integrantes: identificação nominal pendente da equipe.</a:t>
+              <a:t>Enunciado do Projeto Final I2A2, fornecido pelo usuário, datado de 15/07/2026. Equipe InsurMinds: Victor Hugo Araujo, João Carlos Mendonça, Adriéli Zacharias e Bruno Veiga.</a:t>
             </a:r>
             <a:endParaRPr lang="en-US" dirty="0"/>
           </a:p>
@@ -1037,7 +1037,7 @@
           <a:p>
             <a:r>
               <a:rPr lang="en-US" dirty="0"/>
-              <a:t>Resultados da execução local de tests/test_pipeline.py e scripts/check_ui.py. Não houve acesso a credencial de IA. Comparação é textual e revisão humana continua necessária.</a:t>
+              <a:t>Testes automatizados e fluxo de interface executados. A equipe também validou uma extração real com Gemini usando PDFs fictícios. Isso não mede a precisão em apólices de mercado. A comparação é textual e requer revisão humana.</a:t>
             </a:r>
             <a:endParaRPr lang="en-US" dirty="0"/>
           </a:p>
@@ -1125,7 +1125,7 @@
           <a:p>
             <a:r>
               <a:rPr lang="en-US" dirty="0"/>
-              <a:t>Prazo do enunciado: 06/10/2026 às 23h59. Repositório público: https://github.com/vicTmm/i2a2-desafio-final. A validação com IA real e a identificação nominal dos integrantes ainda precisam ser concluídas.</a:t>
+              <a:t>Prazo informado no enunciado: 06/10/2026 às 23h59. Repositório público: https://github.com/vicTmm/i2a2-desafio-final. A equipe testou o fluxo com Gemini em documentos fictícios; a precisão em apólices de mercado ainda requer avaliação especializada.</a:t>
             </a:r>
             <a:endParaRPr lang="en-US" dirty="0"/>
           </a:p>
@@ -2166,7 +2166,7 @@
       </p:sp>
       <p:pic>
         <p:nvPicPr>
-          <p:cNvPr id="5" name="Image 0" descr="C:\Projetos\i2a2-desafio-final\tmp\ui\overview.png">    </p:cNvPr>
+          <p:cNvPr id="5" name="Image 0" descr="C:\Users\Lívia Paraquett\OneDrive\Documentos\Victor Hugo\Projetos\i2a2-desafio-final\tmp\ui\overview.png">    </p:cNvPr>
           <p:cNvPicPr>
             <a:picLocks noChangeAspect="1"/>
           </p:cNvPicPr>
@@ -4831,7 +4831,7 @@
                 <a:ea typeface="Aptos" pitchFamily="34" charset="-122"/>
                 <a:cs typeface="Aptos" pitchFamily="34" charset="-120"/>
               </a:rPr>
-              <a:t>Pendente: validar uma chamada real de IA com a chave da equipe.</a:t>
+              <a:t>Validação funcional: extração real com Gemini em PDFs fictícios. Precisão em apólices de mercado ainda não avaliada.</a:t>
             </a:r>
             <a:endParaRPr lang="en-US" sz="2600" dirty="0"/>
           </a:p>
@@ -4870,7 +4870,7 @@
                 <a:ea typeface="Aptos" pitchFamily="34" charset="-122"/>
                 <a:cs typeface="Aptos" pitchFamily="34" charset="-120"/>
               </a:rPr>
-              <a:t>Os testes usam respostas controladas. Ainda não há avaliação de precisão em apólices de mercado.</a:t>
+              <a:t>A precisão em apólices reais ainda requer avaliação especializada.</a:t>
             </a:r>
             <a:endParaRPr lang="en-US" sz="1800" dirty="0"/>
           </a:p>
@@ -5145,7 +5145,7 @@
               <a:buNone/>
             </a:pPr>
             <a:r>
-              <a:rPr lang="en-US" sz="2300" dirty="0">
+              <a:rPr lang="en-US" sz="1600" dirty="0">
                 <a:solidFill>
                   <a:srgbClr val="5D7C42"/>
                 </a:solidFill>
@@ -5153,9 +5153,26 @@
                 <a:ea typeface="Aptos" pitchFamily="34" charset="-122"/>
                 <a:cs typeface="Aptos" pitchFamily="34" charset="-120"/>
               </a:rPr>
-              <a:t>Entrega: identificar integrantes, concluir a demonstração com IA e tornar o repositório público.</a:t>
-            </a:r>
-            <a:endParaRPr lang="en-US" sz="2300" dirty="0"/>
+              <a:t>Equipe: Victor Hugo Araujo, João Carlos Mendonça, Adriéli Zacharias e Bruno Veiga.</a:t>
+            </a:r>
+            <a:endParaRPr lang="en-US" sz="1600" dirty="0"/>
+          </a:p>
+          <a:p>
+            <a:pPr indent="0" marL="0">
+              <a:buNone/>
+            </a:pPr>
+            <a:r>
+              <a:rPr lang="en-US" sz="1600" dirty="0">
+                <a:solidFill>
+                  <a:srgbClr val="5D7C42"/>
+                </a:solidFill>
+                <a:latin typeface="Aptos" pitchFamily="34" charset="0"/>
+                <a:ea typeface="Aptos" pitchFamily="34" charset="-122"/>
+                <a:cs typeface="Aptos" pitchFamily="34" charset="-120"/>
+              </a:rPr>
+              <a:t>Repositório público; avaliação especializada em apólices de mercado pendente.</a:t>
+            </a:r>
+            <a:endParaRPr lang="en-US" sz="1600" dirty="0"/>
           </a:p>
         </p:txBody>
       </p:sp>

</xml_diff>

<commit_message>
feat: support long policies and finalize I2A2 delivery
</commit_message>
<xml_diff>
--- a/Projeto_Final_Artefatos/InsurMinds_Projeto_Final.pptx
+++ b/Projeto_Final_Artefatos/InsurMinds_Projeto_Final.pptx
@@ -685,7 +685,7 @@
           <a:p>
             <a:r>
               <a:rPr lang="en-US" dirty="0"/>
-              <a:t>Captura real da aplicação local. Dados exibidos são exemplos sintéticos e pré-preenchidos. Não representam execução real do modelo.</a:t>
+              <a:t>Captura real da aplicação local. Dados exibidos são documentos fictícios efetivamente enviados à análise real com Gemini 3.8 Flash; registro em Validacao_IA_Exemplos.json.</a:t>
             </a:r>
             <a:endParaRPr lang="en-US" dirty="0"/>
           </a:p>
@@ -949,7 +949,7 @@
           <a:p>
             <a:r>
               <a:rPr lang="en-US" dirty="0"/>
-              <a:t>Fonte: backend/demo.py e comparação determinística. Não é benchmark de precisão da IA nem comparação de produtos reais.</a:t>
+              <a:t>Fonte: PDFs fictícios autorais, extração real Gemini 3.8 Flash e comparação determinística. Não é benchmark de precisão da IA nem comparação de produtos reais.</a:t>
             </a:r>
             <a:endParaRPr lang="en-US" dirty="0"/>
           </a:p>
@@ -1037,7 +1037,7 @@
           <a:p>
             <a:r>
               <a:rPr lang="en-US" dirty="0"/>
-              <a:t>Testes automatizados e fluxo de interface executados. A equipe também validou uma extração real com Gemini usando PDFs fictícios. Isso não mede a precisão em apólices de mercado. A comparação é textual e requer revisão humana.</a:t>
+              <a:t>Testes automatizados e fluxo de interface executados. A equipe também validou duas extrações reais com Gemini 3.8 Flash usando PDFs fictícios. Isso não mede a precisão em apólices de mercado. A comparação é textual e requer revisão humana.</a:t>
             </a:r>
             <a:endParaRPr lang="en-US" dirty="0"/>
           </a:p>
@@ -1527,9 +1527,9 @@
                 <a:solidFill>
                   <a:srgbClr val="244B3B"/>
                 </a:solidFill>
-                <a:latin typeface="Aptos Display" pitchFamily="34" charset="0"/>
-                <a:ea typeface="Aptos Display" pitchFamily="34" charset="-122"/>
-                <a:cs typeface="Aptos Display" pitchFamily="34" charset="-120"/>
+                <a:latin typeface="Arial" pitchFamily="34" charset="0"/>
+                <a:ea typeface="Arial" pitchFamily="34" charset="-122"/>
+                <a:cs typeface="Arial" pitchFamily="34" charset="-120"/>
               </a:rPr>
               <a:t>InsurMinds</a:t>
             </a:r>
@@ -1566,9 +1566,9 @@
                 <a:solidFill>
                   <a:srgbClr val="66755D"/>
                 </a:solidFill>
-                <a:latin typeface="Aptos" pitchFamily="34" charset="0"/>
-                <a:ea typeface="Aptos" pitchFamily="34" charset="-122"/>
-                <a:cs typeface="Aptos" pitchFamily="34" charset="-120"/>
+                <a:latin typeface="Arial" pitchFamily="34" charset="0"/>
+                <a:ea typeface="Arial" pitchFamily="34" charset="-122"/>
+                <a:cs typeface="Arial" pitchFamily="34" charset="-120"/>
               </a:rPr>
               <a:t>InsurMinds / I2A2 2026</a:t>
             </a:r>
@@ -1605,9 +1605,9 @@
                 <a:solidFill>
                   <a:srgbClr val="66755D"/>
                 </a:solidFill>
-                <a:latin typeface="Aptos" pitchFamily="34" charset="0"/>
-                <a:ea typeface="Aptos" pitchFamily="34" charset="-122"/>
-                <a:cs typeface="Aptos" pitchFamily="34" charset="-120"/>
+                <a:latin typeface="Arial" pitchFamily="34" charset="0"/>
+                <a:ea typeface="Arial" pitchFamily="34" charset="-122"/>
+                <a:cs typeface="Arial" pitchFamily="34" charset="-120"/>
               </a:rPr>
               <a:t>01</a:t>
             </a:r>
@@ -1644,9 +1644,9 @@
                 <a:solidFill>
                   <a:srgbClr val="244B3B"/>
                 </a:solidFill>
-                <a:latin typeface="Aptos Display" pitchFamily="34" charset="0"/>
-                <a:ea typeface="Aptos Display" pitchFamily="34" charset="-122"/>
-                <a:cs typeface="Aptos Display" pitchFamily="34" charset="-120"/>
+                <a:latin typeface="Arial" pitchFamily="34" charset="0"/>
+                <a:ea typeface="Arial" pitchFamily="34" charset="-122"/>
+                <a:cs typeface="Arial" pitchFamily="34" charset="-120"/>
               </a:rPr>
               <a:t>Clareza na comparação</a:t>
             </a:r>
@@ -1661,9 +1661,9 @@
                 <a:solidFill>
                   <a:srgbClr val="244B3B"/>
                 </a:solidFill>
-                <a:latin typeface="Aptos Display" pitchFamily="34" charset="0"/>
-                <a:ea typeface="Aptos Display" pitchFamily="34" charset="-122"/>
-                <a:cs typeface="Aptos Display" pitchFamily="34" charset="-120"/>
+                <a:latin typeface="Arial" pitchFamily="34" charset="0"/>
+                <a:ea typeface="Arial" pitchFamily="34" charset="-122"/>
+                <a:cs typeface="Arial" pitchFamily="34" charset="-120"/>
               </a:rPr>
               <a:t>de apólices D&amp;O</a:t>
             </a:r>
@@ -1700,9 +1700,9 @@
                 <a:solidFill>
                   <a:srgbClr val="66755D"/>
                 </a:solidFill>
-                <a:latin typeface="Aptos" pitchFamily="34" charset="0"/>
-                <a:ea typeface="Aptos" pitchFamily="34" charset="-122"/>
-                <a:cs typeface="Aptos" pitchFamily="34" charset="-120"/>
+                <a:latin typeface="Arial" pitchFamily="34" charset="0"/>
+                <a:ea typeface="Arial" pitchFamily="34" charset="-122"/>
+                <a:cs typeface="Arial" pitchFamily="34" charset="-120"/>
               </a:rPr>
               <a:t>Extração com IA e evidências por página</a:t>
             </a:r>
@@ -1739,9 +1739,9 @@
                 <a:solidFill>
                   <a:srgbClr val="66755D"/>
                 </a:solidFill>
-                <a:latin typeface="Aptos" pitchFamily="34" charset="0"/>
-                <a:ea typeface="Aptos" pitchFamily="34" charset="-122"/>
-                <a:cs typeface="Aptos" pitchFamily="34" charset="-120"/>
+                <a:latin typeface="Arial" pitchFamily="34" charset="0"/>
+                <a:ea typeface="Arial" pitchFamily="34" charset="-122"/>
+                <a:cs typeface="Arial" pitchFamily="34" charset="-120"/>
               </a:rPr>
               <a:t>Projeto Final / Instituto de Inteligência Artificial Aplicada</a:t>
             </a:r>
@@ -1810,9 +1810,9 @@
                 <a:solidFill>
                   <a:srgbClr val="244B3B"/>
                 </a:solidFill>
-                <a:latin typeface="Aptos Display" pitchFamily="34" charset="0"/>
-                <a:ea typeface="Aptos Display" pitchFamily="34" charset="-122"/>
-                <a:cs typeface="Aptos Display" pitchFamily="34" charset="-120"/>
+                <a:latin typeface="Arial" pitchFamily="34" charset="0"/>
+                <a:ea typeface="Arial" pitchFamily="34" charset="-122"/>
+                <a:cs typeface="Arial" pitchFamily="34" charset="-120"/>
               </a:rPr>
               <a:t>O problema da leitura documental</a:t>
             </a:r>
@@ -1849,9 +1849,9 @@
                 <a:solidFill>
                   <a:srgbClr val="66755D"/>
                 </a:solidFill>
-                <a:latin typeface="Aptos" pitchFamily="34" charset="0"/>
-                <a:ea typeface="Aptos" pitchFamily="34" charset="-122"/>
-                <a:cs typeface="Aptos" pitchFamily="34" charset="-120"/>
+                <a:latin typeface="Arial" pitchFamily="34" charset="0"/>
+                <a:ea typeface="Arial" pitchFamily="34" charset="-122"/>
+                <a:cs typeface="Arial" pitchFamily="34" charset="-120"/>
               </a:rPr>
               <a:t>InsurMinds / I2A2 2026</a:t>
             </a:r>
@@ -1888,9 +1888,9 @@
                 <a:solidFill>
                   <a:srgbClr val="66755D"/>
                 </a:solidFill>
-                <a:latin typeface="Aptos" pitchFamily="34" charset="0"/>
-                <a:ea typeface="Aptos" pitchFamily="34" charset="-122"/>
-                <a:cs typeface="Aptos" pitchFamily="34" charset="-120"/>
+                <a:latin typeface="Arial" pitchFamily="34" charset="0"/>
+                <a:ea typeface="Arial" pitchFamily="34" charset="-122"/>
+                <a:cs typeface="Arial" pitchFamily="34" charset="-120"/>
               </a:rPr>
               <a:t>02</a:t>
             </a:r>
@@ -1927,9 +1927,9 @@
                 <a:solidFill>
                   <a:srgbClr val="244B3B"/>
                 </a:solidFill>
-                <a:latin typeface="Aptos" pitchFamily="34" charset="0"/>
-                <a:ea typeface="Aptos" pitchFamily="34" charset="-122"/>
-                <a:cs typeface="Aptos" pitchFamily="34" charset="-120"/>
+                <a:latin typeface="Arial" pitchFamily="34" charset="0"/>
+                <a:ea typeface="Arial" pitchFamily="34" charset="-122"/>
+                <a:cs typeface="Arial" pitchFamily="34" charset="-120"/>
               </a:rPr>
               <a:t>O limite de uma apólice não conta toda a história.</a:t>
             </a:r>
@@ -1966,9 +1966,9 @@
                 <a:solidFill>
                   <a:srgbClr val="66755D"/>
                 </a:solidFill>
-                <a:latin typeface="Aptos" pitchFamily="34" charset="0"/>
-                <a:ea typeface="Aptos" pitchFamily="34" charset="-122"/>
-                <a:cs typeface="Aptos" pitchFamily="34" charset="-120"/>
+                <a:latin typeface="Arial" pitchFamily="34" charset="0"/>
+                <a:ea typeface="Arial" pitchFamily="34" charset="-122"/>
+                <a:cs typeface="Arial" pitchFamily="34" charset="-120"/>
               </a:rPr>
               <a:t>Franquias, sub-limites e exclusões mudam a interpretação de uma cobertura. A análise precisa conectar cada informação às condições do documento.</a:t>
             </a:r>
@@ -2005,9 +2005,9 @@
                 <a:solidFill>
                   <a:srgbClr val="5D7C42"/>
                 </a:solidFill>
-                <a:latin typeface="Aptos" pitchFamily="34" charset="0"/>
-                <a:ea typeface="Aptos" pitchFamily="34" charset="-122"/>
-                <a:cs typeface="Aptos" pitchFamily="34" charset="-120"/>
+                <a:latin typeface="Arial" pitchFamily="34" charset="0"/>
+                <a:ea typeface="Arial" pitchFamily="34" charset="-122"/>
+                <a:cs typeface="Arial" pitchFamily="34" charset="-120"/>
               </a:rPr>
               <a:t>Necessidade: localizar diferenças e conferir a origem dos dados.</a:t>
             </a:r>
@@ -2076,9 +2076,9 @@
                 <a:solidFill>
                   <a:srgbClr val="244B3B"/>
                 </a:solidFill>
-                <a:latin typeface="Aptos Display" pitchFamily="34" charset="0"/>
-                <a:ea typeface="Aptos Display" pitchFamily="34" charset="-122"/>
-                <a:cs typeface="Aptos Display" pitchFamily="34" charset="-120"/>
+                <a:latin typeface="Arial" pitchFamily="34" charset="0"/>
+                <a:ea typeface="Arial" pitchFamily="34" charset="-122"/>
+                <a:cs typeface="Arial" pitchFamily="34" charset="-120"/>
               </a:rPr>
               <a:t>A solução em funcionamento</a:t>
             </a:r>
@@ -2115,9 +2115,9 @@
                 <a:solidFill>
                   <a:srgbClr val="66755D"/>
                 </a:solidFill>
-                <a:latin typeface="Aptos" pitchFamily="34" charset="0"/>
-                <a:ea typeface="Aptos" pitchFamily="34" charset="-122"/>
-                <a:cs typeface="Aptos" pitchFamily="34" charset="-120"/>
+                <a:latin typeface="Arial" pitchFamily="34" charset="0"/>
+                <a:ea typeface="Arial" pitchFamily="34" charset="-122"/>
+                <a:cs typeface="Arial" pitchFamily="34" charset="-120"/>
               </a:rPr>
               <a:t>InsurMinds / I2A2 2026</a:t>
             </a:r>
@@ -2154,9 +2154,9 @@
                 <a:solidFill>
                   <a:srgbClr val="66755D"/>
                 </a:solidFill>
-                <a:latin typeface="Aptos" pitchFamily="34" charset="0"/>
-                <a:ea typeface="Aptos" pitchFamily="34" charset="-122"/>
-                <a:cs typeface="Aptos" pitchFamily="34" charset="-120"/>
+                <a:latin typeface="Arial" pitchFamily="34" charset="0"/>
+                <a:ea typeface="Arial" pitchFamily="34" charset="-122"/>
+                <a:cs typeface="Arial" pitchFamily="34" charset="-120"/>
               </a:rPr>
               <a:t>03</a:t>
             </a:r>
@@ -2166,7 +2166,7 @@
       </p:sp>
       <p:pic>
         <p:nvPicPr>
-          <p:cNvPr id="5" name="Image 0" descr="C:\Users\Lívia Paraquett\OneDrive\Documentos\Victor Hugo\Projetos\i2a2-desafio-final\tmp\ui\overview.png">    </p:cNvPr>
+          <p:cNvPr id="5" name="Image 0" descr="/Users/victorhugo/Documents/Projetos/i2a2-desafio-final/tmp/ui/overview.png">    </p:cNvPr>
           <p:cNvPicPr>
             <a:picLocks noChangeAspect="1"/>
           </p:cNvPicPr>
@@ -2217,9 +2217,9 @@
                 <a:solidFill>
                   <a:srgbClr val="244B3B"/>
                 </a:solidFill>
-                <a:latin typeface="Aptos" pitchFamily="34" charset="0"/>
-                <a:ea typeface="Aptos" pitchFamily="34" charset="-122"/>
-                <a:cs typeface="Aptos" pitchFamily="34" charset="-120"/>
+                <a:latin typeface="Arial" pitchFamily="34" charset="0"/>
+                <a:ea typeface="Arial" pitchFamily="34" charset="-122"/>
+                <a:cs typeface="Arial" pitchFamily="34" charset="-120"/>
               </a:rPr>
               <a:t>16 critérios</a:t>
             </a:r>
@@ -2234,9 +2234,9 @@
                 <a:solidFill>
                   <a:srgbClr val="244B3B"/>
                 </a:solidFill>
-                <a:latin typeface="Aptos" pitchFamily="34" charset="0"/>
-                <a:ea typeface="Aptos" pitchFamily="34" charset="-122"/>
-                <a:cs typeface="Aptos" pitchFamily="34" charset="-120"/>
+                <a:latin typeface="Arial" pitchFamily="34" charset="0"/>
+                <a:ea typeface="Arial" pitchFamily="34" charset="-122"/>
+                <a:cs typeface="Arial" pitchFamily="34" charset="-120"/>
               </a:rPr>
               <a:t>por documento</a:t>
             </a:r>
@@ -2273,9 +2273,9 @@
                 <a:solidFill>
                   <a:srgbClr val="66755D"/>
                 </a:solidFill>
-                <a:latin typeface="Aptos" pitchFamily="34" charset="0"/>
-                <a:ea typeface="Aptos" pitchFamily="34" charset="-122"/>
-                <a:cs typeface="Aptos" pitchFamily="34" charset="-120"/>
+                <a:latin typeface="Arial" pitchFamily="34" charset="0"/>
+                <a:ea typeface="Arial" pitchFamily="34" charset="-122"/>
+                <a:cs typeface="Arial" pitchFamily="34" charset="-120"/>
               </a:rPr>
               <a:t>Biblioteca pesquisável, comparação de até quatro apólices e consulta às evidências.</a:t>
             </a:r>
@@ -2344,9 +2344,9 @@
                 <a:solidFill>
                   <a:srgbClr val="244B3B"/>
                 </a:solidFill>
-                <a:latin typeface="Aptos Display" pitchFamily="34" charset="0"/>
-                <a:ea typeface="Aptos Display" pitchFamily="34" charset="-122"/>
-                <a:cs typeface="Aptos Display" pitchFamily="34" charset="-120"/>
+                <a:latin typeface="Arial" pitchFamily="34" charset="0"/>
+                <a:ea typeface="Arial" pitchFamily="34" charset="-122"/>
+                <a:cs typeface="Arial" pitchFamily="34" charset="-120"/>
               </a:rPr>
               <a:t>Arquitetura do MVP</a:t>
             </a:r>
@@ -2383,9 +2383,9 @@
                 <a:solidFill>
                   <a:srgbClr val="66755D"/>
                 </a:solidFill>
-                <a:latin typeface="Aptos" pitchFamily="34" charset="0"/>
-                <a:ea typeface="Aptos" pitchFamily="34" charset="-122"/>
-                <a:cs typeface="Aptos" pitchFamily="34" charset="-120"/>
+                <a:latin typeface="Arial" pitchFamily="34" charset="0"/>
+                <a:ea typeface="Arial" pitchFamily="34" charset="-122"/>
+                <a:cs typeface="Arial" pitchFamily="34" charset="-120"/>
               </a:rPr>
               <a:t>InsurMinds / I2A2 2026</a:t>
             </a:r>
@@ -2422,9 +2422,9 @@
                 <a:solidFill>
                   <a:srgbClr val="66755D"/>
                 </a:solidFill>
-                <a:latin typeface="Aptos" pitchFamily="34" charset="0"/>
-                <a:ea typeface="Aptos" pitchFamily="34" charset="-122"/>
-                <a:cs typeface="Aptos" pitchFamily="34" charset="-120"/>
+                <a:latin typeface="Arial" pitchFamily="34" charset="0"/>
+                <a:ea typeface="Arial" pitchFamily="34" charset="-122"/>
+                <a:cs typeface="Arial" pitchFamily="34" charset="-120"/>
               </a:rPr>
               <a:t>04</a:t>
             </a:r>
@@ -2461,9 +2461,9 @@
                 <a:solidFill>
                   <a:srgbClr val="244B3B"/>
                 </a:solidFill>
-                <a:latin typeface="Aptos" pitchFamily="34" charset="0"/>
-                <a:ea typeface="Aptos" pitchFamily="34" charset="-122"/>
-                <a:cs typeface="Aptos" pitchFamily="34" charset="-120"/>
+                <a:latin typeface="Arial" pitchFamily="34" charset="0"/>
+                <a:ea typeface="Arial" pitchFamily="34" charset="-122"/>
+                <a:cs typeface="Arial" pitchFamily="34" charset="-120"/>
               </a:rPr>
               <a:t>React / TypeScript</a:t>
             </a:r>
@@ -2500,9 +2500,9 @@
                 <a:solidFill>
                   <a:srgbClr val="66755D"/>
                 </a:solidFill>
-                <a:latin typeface="Aptos" pitchFamily="34" charset="0"/>
-                <a:ea typeface="Aptos" pitchFamily="34" charset="-122"/>
-                <a:cs typeface="Aptos" pitchFamily="34" charset="-120"/>
+                <a:latin typeface="Arial" pitchFamily="34" charset="0"/>
+                <a:ea typeface="Arial" pitchFamily="34" charset="-122"/>
+                <a:cs typeface="Arial" pitchFamily="34" charset="-120"/>
               </a:rPr>
               <a:t>Interface</a:t>
             </a:r>
@@ -2539,9 +2539,9 @@
                 <a:solidFill>
                   <a:srgbClr val="244B3B"/>
                 </a:solidFill>
-                <a:latin typeface="Aptos" pitchFamily="34" charset="0"/>
-                <a:ea typeface="Aptos" pitchFamily="34" charset="-122"/>
-                <a:cs typeface="Aptos" pitchFamily="34" charset="-120"/>
+                <a:latin typeface="Arial" pitchFamily="34" charset="0"/>
+                <a:ea typeface="Arial" pitchFamily="34" charset="-122"/>
+                <a:cs typeface="Arial" pitchFamily="34" charset="-120"/>
               </a:rPr>
               <a:t>Python / Starlette</a:t>
             </a:r>
@@ -2578,9 +2578,9 @@
                 <a:solidFill>
                   <a:srgbClr val="66755D"/>
                 </a:solidFill>
-                <a:latin typeface="Aptos" pitchFamily="34" charset="0"/>
-                <a:ea typeface="Aptos" pitchFamily="34" charset="-122"/>
-                <a:cs typeface="Aptos" pitchFamily="34" charset="-120"/>
+                <a:latin typeface="Arial" pitchFamily="34" charset="0"/>
+                <a:ea typeface="Arial" pitchFamily="34" charset="-122"/>
+                <a:cs typeface="Arial" pitchFamily="34" charset="-120"/>
               </a:rPr>
               <a:t>API</a:t>
             </a:r>
@@ -2617,9 +2617,9 @@
                 <a:solidFill>
                   <a:srgbClr val="244B3B"/>
                 </a:solidFill>
-                <a:latin typeface="Aptos" pitchFamily="34" charset="0"/>
-                <a:ea typeface="Aptos" pitchFamily="34" charset="-122"/>
-                <a:cs typeface="Aptos" pitchFamily="34" charset="-120"/>
+                <a:latin typeface="Arial" pitchFamily="34" charset="0"/>
+                <a:ea typeface="Arial" pitchFamily="34" charset="-122"/>
+                <a:cs typeface="Arial" pitchFamily="34" charset="-120"/>
               </a:rPr>
               <a:t>Texto + visão</a:t>
             </a:r>
@@ -2656,9 +2656,9 @@
                 <a:solidFill>
                   <a:srgbClr val="66755D"/>
                 </a:solidFill>
-                <a:latin typeface="Aptos" pitchFamily="34" charset="0"/>
-                <a:ea typeface="Aptos" pitchFamily="34" charset="-122"/>
-                <a:cs typeface="Aptos" pitchFamily="34" charset="-120"/>
+                <a:latin typeface="Arial" pitchFamily="34" charset="0"/>
+                <a:ea typeface="Arial" pitchFamily="34" charset="-122"/>
+                <a:cs typeface="Arial" pitchFamily="34" charset="-120"/>
               </a:rPr>
               <a:t>Leitura</a:t>
             </a:r>
@@ -2695,9 +2695,9 @@
                 <a:solidFill>
                   <a:srgbClr val="244B3B"/>
                 </a:solidFill>
-                <a:latin typeface="Aptos" pitchFamily="34" charset="0"/>
-                <a:ea typeface="Aptos" pitchFamily="34" charset="-122"/>
-                <a:cs typeface="Aptos" pitchFamily="34" charset="-120"/>
+                <a:latin typeface="Arial" pitchFamily="34" charset="0"/>
+                <a:ea typeface="Arial" pitchFamily="34" charset="-122"/>
+                <a:cs typeface="Arial" pitchFamily="34" charset="-120"/>
               </a:rPr>
               <a:t>Gemini + Pydantic</a:t>
             </a:r>
@@ -2734,9 +2734,9 @@
                 <a:solidFill>
                   <a:srgbClr val="66755D"/>
                 </a:solidFill>
-                <a:latin typeface="Aptos" pitchFamily="34" charset="0"/>
-                <a:ea typeface="Aptos" pitchFamily="34" charset="-122"/>
-                <a:cs typeface="Aptos" pitchFamily="34" charset="-120"/>
+                <a:latin typeface="Arial" pitchFamily="34" charset="0"/>
+                <a:ea typeface="Arial" pitchFamily="34" charset="-122"/>
+                <a:cs typeface="Arial" pitchFamily="34" charset="-120"/>
               </a:rPr>
               <a:t>Extração e validação</a:t>
             </a:r>
@@ -2773,9 +2773,9 @@
                 <a:solidFill>
                   <a:srgbClr val="244B3B"/>
                 </a:solidFill>
-                <a:latin typeface="Aptos" pitchFamily="34" charset="0"/>
-                <a:ea typeface="Aptos" pitchFamily="34" charset="-122"/>
-                <a:cs typeface="Aptos" pitchFamily="34" charset="-120"/>
+                <a:latin typeface="Arial" pitchFamily="34" charset="0"/>
+                <a:ea typeface="Arial" pitchFamily="34" charset="-122"/>
+                <a:cs typeface="Arial" pitchFamily="34" charset="-120"/>
               </a:rPr>
               <a:t>SQLite</a:t>
             </a:r>
@@ -2812,9 +2812,9 @@
                 <a:solidFill>
                   <a:srgbClr val="66755D"/>
                 </a:solidFill>
-                <a:latin typeface="Aptos" pitchFamily="34" charset="0"/>
-                <a:ea typeface="Aptos" pitchFamily="34" charset="-122"/>
-                <a:cs typeface="Aptos" pitchFamily="34" charset="-120"/>
+                <a:latin typeface="Arial" pitchFamily="34" charset="0"/>
+                <a:ea typeface="Arial" pitchFamily="34" charset="-122"/>
+                <a:cs typeface="Arial" pitchFamily="34" charset="-120"/>
               </a:rPr>
               <a:t>Persistência</a:t>
             </a:r>
@@ -2851,9 +2851,9 @@
                 <a:solidFill>
                   <a:srgbClr val="244B3B"/>
                 </a:solidFill>
-                <a:latin typeface="Aptos" pitchFamily="34" charset="0"/>
-                <a:ea typeface="Aptos" pitchFamily="34" charset="-122"/>
-                <a:cs typeface="Aptos" pitchFamily="34" charset="-120"/>
+                <a:latin typeface="Arial" pitchFamily="34" charset="0"/>
+                <a:ea typeface="Arial" pitchFamily="34" charset="-122"/>
+                <a:cs typeface="Arial" pitchFamily="34" charset="-120"/>
               </a:rPr>
               <a:t>Comparação + PDF</a:t>
             </a:r>
@@ -2890,9 +2890,9 @@
                 <a:solidFill>
                   <a:srgbClr val="66755D"/>
                 </a:solidFill>
-                <a:latin typeface="Aptos" pitchFamily="34" charset="0"/>
-                <a:ea typeface="Aptos" pitchFamily="34" charset="-122"/>
-                <a:cs typeface="Aptos" pitchFamily="34" charset="-120"/>
+                <a:latin typeface="Arial" pitchFamily="34" charset="0"/>
+                <a:ea typeface="Arial" pitchFamily="34" charset="-122"/>
+                <a:cs typeface="Arial" pitchFamily="34" charset="-120"/>
               </a:rPr>
               <a:t>Resultado</a:t>
             </a:r>
@@ -2929,11 +2929,11 @@
                 <a:solidFill>
                   <a:srgbClr val="5D7C42"/>
                 </a:solidFill>
-                <a:latin typeface="Aptos" pitchFamily="34" charset="0"/>
-                <a:ea typeface="Aptos" pitchFamily="34" charset="-122"/>
-                <a:cs typeface="Aptos" pitchFamily="34" charset="-120"/>
-              </a:rPr>
-              <a:t>Pipeline especializado com IA na extração e na consulta.</a:t>
+                <a:latin typeface="Arial" pitchFamily="34" charset="0"/>
+                <a:ea typeface="Arial" pitchFamily="34" charset="-122"/>
+                <a:cs typeface="Arial" pitchFamily="34" charset="-120"/>
+              </a:rPr>
+              <a:t>Blocos, checkpoints e múltiplas evidências por critério.</a:t>
             </a:r>
             <a:endParaRPr lang="en-US" sz="2000" dirty="0"/>
           </a:p>
@@ -3000,9 +3000,9 @@
                 <a:solidFill>
                   <a:srgbClr val="244B3B"/>
                 </a:solidFill>
-                <a:latin typeface="Aptos Display" pitchFamily="34" charset="0"/>
-                <a:ea typeface="Aptos Display" pitchFamily="34" charset="-122"/>
-                <a:cs typeface="Aptos Display" pitchFamily="34" charset="-120"/>
+                <a:latin typeface="Arial" pitchFamily="34" charset="0"/>
+                <a:ea typeface="Arial" pitchFamily="34" charset="-122"/>
+                <a:cs typeface="Arial" pitchFamily="34" charset="-120"/>
               </a:rPr>
               <a:t>Cada informação tem uma origem</a:t>
             </a:r>
@@ -3039,9 +3039,9 @@
                 <a:solidFill>
                   <a:srgbClr val="66755D"/>
                 </a:solidFill>
-                <a:latin typeface="Aptos" pitchFamily="34" charset="0"/>
-                <a:ea typeface="Aptos" pitchFamily="34" charset="-122"/>
-                <a:cs typeface="Aptos" pitchFamily="34" charset="-120"/>
+                <a:latin typeface="Arial" pitchFamily="34" charset="0"/>
+                <a:ea typeface="Arial" pitchFamily="34" charset="-122"/>
+                <a:cs typeface="Arial" pitchFamily="34" charset="-120"/>
               </a:rPr>
               <a:t>InsurMinds / I2A2 2026</a:t>
             </a:r>
@@ -3078,9 +3078,9 @@
                 <a:solidFill>
                   <a:srgbClr val="66755D"/>
                 </a:solidFill>
-                <a:latin typeface="Aptos" pitchFamily="34" charset="0"/>
-                <a:ea typeface="Aptos" pitchFamily="34" charset="-122"/>
-                <a:cs typeface="Aptos" pitchFamily="34" charset="-120"/>
+                <a:latin typeface="Arial" pitchFamily="34" charset="0"/>
+                <a:ea typeface="Arial" pitchFamily="34" charset="-122"/>
+                <a:cs typeface="Arial" pitchFamily="34" charset="-120"/>
               </a:rPr>
               <a:t>05</a:t>
             </a:r>
@@ -3117,9 +3117,9 @@
                 <a:solidFill>
                   <a:srgbClr val="66755D"/>
                 </a:solidFill>
-                <a:latin typeface="Aptos" pitchFamily="34" charset="0"/>
-                <a:ea typeface="Aptos" pitchFamily="34" charset="-122"/>
-                <a:cs typeface="Aptos" pitchFamily="34" charset="-120"/>
+                <a:latin typeface="Arial" pitchFamily="34" charset="0"/>
+                <a:ea typeface="Arial" pitchFamily="34" charset="-122"/>
+                <a:cs typeface="Arial" pitchFamily="34" charset="-120"/>
               </a:rPr>
               <a:t>Valor extraído</a:t>
             </a:r>
@@ -3156,9 +3156,9 @@
                 <a:solidFill>
                   <a:srgbClr val="244B3B"/>
                 </a:solidFill>
-                <a:latin typeface="Aptos" pitchFamily="34" charset="0"/>
-                <a:ea typeface="Aptos" pitchFamily="34" charset="-122"/>
-                <a:cs typeface="Aptos" pitchFamily="34" charset="-120"/>
+                <a:latin typeface="Arial" pitchFamily="34" charset="0"/>
+                <a:ea typeface="Arial" pitchFamily="34" charset="-122"/>
+                <a:cs typeface="Arial" pitchFamily="34" charset="-120"/>
               </a:rPr>
               <a:t>R$ 15 milhões</a:t>
             </a:r>
@@ -3195,9 +3195,9 @@
                 <a:solidFill>
                   <a:srgbClr val="66755D"/>
                 </a:solidFill>
-                <a:latin typeface="Aptos" pitchFamily="34" charset="0"/>
-                <a:ea typeface="Aptos" pitchFamily="34" charset="-122"/>
-                <a:cs typeface="Aptos" pitchFamily="34" charset="-120"/>
+                <a:latin typeface="Arial" pitchFamily="34" charset="0"/>
+                <a:ea typeface="Arial" pitchFamily="34" charset="-122"/>
+                <a:cs typeface="Arial" pitchFamily="34" charset="-120"/>
               </a:rPr>
               <a:t>Evidência na página 1</a:t>
             </a:r>
@@ -3234,9 +3234,9 @@
                 <a:solidFill>
                   <a:srgbClr val="244B3B"/>
                 </a:solidFill>
-                <a:latin typeface="Aptos" pitchFamily="34" charset="0"/>
-                <a:ea typeface="Aptos" pitchFamily="34" charset="-122"/>
-                <a:cs typeface="Aptos" pitchFamily="34" charset="-120"/>
+                <a:latin typeface="Arial" pitchFamily="34" charset="0"/>
+                <a:ea typeface="Arial" pitchFamily="34" charset="-122"/>
+                <a:cs typeface="Arial" pitchFamily="34" charset="-120"/>
               </a:rPr>
               <a:t>“Limite de responsabilidade: BRL 15.000.000,00.”</a:t>
             </a:r>
@@ -3273,9 +3273,9 @@
                 <a:solidFill>
                   <a:srgbClr val="66755D"/>
                 </a:solidFill>
-                <a:latin typeface="Aptos" pitchFamily="34" charset="0"/>
-                <a:ea typeface="Aptos" pitchFamily="34" charset="-122"/>
-                <a:cs typeface="Aptos" pitchFamily="34" charset="-120"/>
+                <a:latin typeface="Arial" pitchFamily="34" charset="0"/>
+                <a:ea typeface="Arial" pitchFamily="34" charset="-122"/>
+                <a:cs typeface="Arial" pitchFamily="34" charset="-120"/>
               </a:rPr>
               <a:t>Trechos de texto são conferidos automaticamente. Leituras de imagens exigem revisão visual. Dado ausente permanece não identificado.</a:t>
             </a:r>
@@ -3344,9 +3344,9 @@
                 <a:solidFill>
                   <a:srgbClr val="244B3B"/>
                 </a:solidFill>
-                <a:latin typeface="Aptos Display" pitchFamily="34" charset="0"/>
-                <a:ea typeface="Aptos Display" pitchFamily="34" charset="-122"/>
-                <a:cs typeface="Aptos Display" pitchFamily="34" charset="-120"/>
+                <a:latin typeface="Arial" pitchFamily="34" charset="0"/>
+                <a:ea typeface="Arial" pitchFamily="34" charset="-122"/>
+                <a:cs typeface="Arial" pitchFamily="34" charset="-120"/>
               </a:rPr>
               <a:t>Comparação demonstrativa</a:t>
             </a:r>
@@ -3383,9 +3383,9 @@
                 <a:solidFill>
                   <a:srgbClr val="66755D"/>
                 </a:solidFill>
-                <a:latin typeface="Aptos" pitchFamily="34" charset="0"/>
-                <a:ea typeface="Aptos" pitchFamily="34" charset="-122"/>
-                <a:cs typeface="Aptos" pitchFamily="34" charset="-120"/>
+                <a:latin typeface="Arial" pitchFamily="34" charset="0"/>
+                <a:ea typeface="Arial" pitchFamily="34" charset="-122"/>
+                <a:cs typeface="Arial" pitchFamily="34" charset="-120"/>
               </a:rPr>
               <a:t>InsurMinds / I2A2 2026</a:t>
             </a:r>
@@ -3422,9 +3422,9 @@
                 <a:solidFill>
                   <a:srgbClr val="66755D"/>
                 </a:solidFill>
-                <a:latin typeface="Aptos" pitchFamily="34" charset="0"/>
-                <a:ea typeface="Aptos" pitchFamily="34" charset="-122"/>
-                <a:cs typeface="Aptos" pitchFamily="34" charset="-120"/>
+                <a:latin typeface="Arial" pitchFamily="34" charset="0"/>
+                <a:ea typeface="Arial" pitchFamily="34" charset="-122"/>
+                <a:cs typeface="Arial" pitchFamily="34" charset="-120"/>
               </a:rPr>
               <a:t>06</a:t>
             </a:r>
@@ -3473,16 +3473,16 @@
                           <a:solidFill>
                             <a:srgbClr val="244B3B"/>
                           </a:solidFill>
-                          <a:latin typeface="Aptos" pitchFamily="34" charset="0"/>
-                          <a:ea typeface="Aptos" pitchFamily="34" charset="-122"/>
-                          <a:cs typeface="Aptos" pitchFamily="34" charset="-120"/>
+                          <a:latin typeface="Arial" pitchFamily="34" charset="0"/>
+                          <a:ea typeface="Arial" pitchFamily="34" charset="-122"/>
+                          <a:cs typeface="Arial" pitchFamily="34" charset="-120"/>
                         </a:rPr>
                         <a:t>Critério</a:t>
                       </a:r>
                       <a:endParaRPr lang="en-US" sz="2200" dirty="0">
-                        <a:latin typeface="Aptos" charset="0"/>
-                        <a:ea typeface="Aptos" charset="0"/>
-                        <a:cs typeface="Aptos" charset="0"/>
+                        <a:latin typeface="Arial" charset="0"/>
+                        <a:ea typeface="Arial" charset="0"/>
+                        <a:cs typeface="Arial" charset="0"/>
                       </a:endParaRPr>
                     </a:p>
                   </a:txBody>
@@ -3541,16 +3541,16 @@
                           <a:solidFill>
                             <a:srgbClr val="244B3B"/>
                           </a:solidFill>
-                          <a:latin typeface="Aptos" pitchFamily="34" charset="0"/>
-                          <a:ea typeface="Aptos" pitchFamily="34" charset="-122"/>
-                          <a:cs typeface="Aptos" pitchFamily="34" charset="-120"/>
+                          <a:latin typeface="Arial" pitchFamily="34" charset="0"/>
+                          <a:ea typeface="Arial" pitchFamily="34" charset="-122"/>
+                          <a:cs typeface="Arial" pitchFamily="34" charset="-120"/>
                         </a:rPr>
                         <a:t>Aurora / fictícia</a:t>
                       </a:r>
                       <a:endParaRPr lang="en-US" sz="2200" dirty="0">
-                        <a:latin typeface="Aptos" charset="0"/>
-                        <a:ea typeface="Aptos" charset="0"/>
-                        <a:cs typeface="Aptos" charset="0"/>
+                        <a:latin typeface="Arial" charset="0"/>
+                        <a:ea typeface="Arial" charset="0"/>
+                        <a:cs typeface="Arial" charset="0"/>
                       </a:endParaRPr>
                     </a:p>
                   </a:txBody>
@@ -3609,16 +3609,16 @@
                           <a:solidFill>
                             <a:srgbClr val="244B3B"/>
                           </a:solidFill>
-                          <a:latin typeface="Aptos" pitchFamily="34" charset="0"/>
-                          <a:ea typeface="Aptos" pitchFamily="34" charset="-122"/>
-                          <a:cs typeface="Aptos" pitchFamily="34" charset="-120"/>
+                          <a:latin typeface="Arial" pitchFamily="34" charset="0"/>
+                          <a:ea typeface="Arial" pitchFamily="34" charset="-122"/>
+                          <a:cs typeface="Arial" pitchFamily="34" charset="-120"/>
                         </a:rPr>
                         <a:t>Vértice / fictícia</a:t>
                       </a:r>
                       <a:endParaRPr lang="en-US" sz="2200" dirty="0">
-                        <a:latin typeface="Aptos" charset="0"/>
-                        <a:ea typeface="Aptos" charset="0"/>
-                        <a:cs typeface="Aptos" charset="0"/>
+                        <a:latin typeface="Arial" charset="0"/>
+                        <a:ea typeface="Arial" charset="0"/>
+                        <a:cs typeface="Arial" charset="0"/>
                       </a:endParaRPr>
                     </a:p>
                   </a:txBody>
@@ -3679,16 +3679,16 @@
                           <a:solidFill>
                             <a:srgbClr val="244B3B"/>
                           </a:solidFill>
-                          <a:latin typeface="Aptos" pitchFamily="34" charset="0"/>
-                          <a:ea typeface="Aptos" pitchFamily="34" charset="-122"/>
-                          <a:cs typeface="Aptos" pitchFamily="34" charset="-120"/>
+                          <a:latin typeface="Arial" pitchFamily="34" charset="0"/>
+                          <a:ea typeface="Arial" pitchFamily="34" charset="-122"/>
+                          <a:cs typeface="Arial" pitchFamily="34" charset="-120"/>
                         </a:rPr>
                         <a:t>Limite agregado</a:t>
                       </a:r>
                       <a:endParaRPr lang="en-US" sz="2200" dirty="0">
-                        <a:latin typeface="Aptos" charset="0"/>
-                        <a:ea typeface="Aptos" charset="0"/>
-                        <a:cs typeface="Aptos" charset="0"/>
+                        <a:latin typeface="Arial" charset="0"/>
+                        <a:ea typeface="Arial" charset="0"/>
+                        <a:cs typeface="Arial" charset="0"/>
                       </a:endParaRPr>
                     </a:p>
                   </a:txBody>
@@ -3747,16 +3747,16 @@
                           <a:solidFill>
                             <a:srgbClr val="244B3B"/>
                           </a:solidFill>
-                          <a:latin typeface="Aptos" pitchFamily="34" charset="0"/>
-                          <a:ea typeface="Aptos" pitchFamily="34" charset="-122"/>
-                          <a:cs typeface="Aptos" pitchFamily="34" charset="-120"/>
+                          <a:latin typeface="Arial" pitchFamily="34" charset="0"/>
+                          <a:ea typeface="Arial" pitchFamily="34" charset="-122"/>
+                          <a:cs typeface="Arial" pitchFamily="34" charset="-120"/>
                         </a:rPr>
                         <a:t>R$ 10 milhões</a:t>
                       </a:r>
                       <a:endParaRPr lang="en-US" sz="2200" dirty="0">
-                        <a:latin typeface="Aptos" charset="0"/>
-                        <a:ea typeface="Aptos" charset="0"/>
-                        <a:cs typeface="Aptos" charset="0"/>
+                        <a:latin typeface="Arial" charset="0"/>
+                        <a:ea typeface="Arial" charset="0"/>
+                        <a:cs typeface="Arial" charset="0"/>
                       </a:endParaRPr>
                     </a:p>
                   </a:txBody>
@@ -3815,16 +3815,16 @@
                           <a:solidFill>
                             <a:srgbClr val="244B3B"/>
                           </a:solidFill>
-                          <a:latin typeface="Aptos" pitchFamily="34" charset="0"/>
-                          <a:ea typeface="Aptos" pitchFamily="34" charset="-122"/>
-                          <a:cs typeface="Aptos" pitchFamily="34" charset="-120"/>
+                          <a:latin typeface="Arial" pitchFamily="34" charset="0"/>
+                          <a:ea typeface="Arial" pitchFamily="34" charset="-122"/>
+                          <a:cs typeface="Arial" pitchFamily="34" charset="-120"/>
                         </a:rPr>
                         <a:t>R$ 15 milhões</a:t>
                       </a:r>
                       <a:endParaRPr lang="en-US" sz="2200" dirty="0">
-                        <a:latin typeface="Aptos" charset="0"/>
-                        <a:ea typeface="Aptos" charset="0"/>
-                        <a:cs typeface="Aptos" charset="0"/>
+                        <a:latin typeface="Arial" charset="0"/>
+                        <a:ea typeface="Arial" charset="0"/>
+                        <a:cs typeface="Arial" charset="0"/>
                       </a:endParaRPr>
                     </a:p>
                   </a:txBody>
@@ -3885,16 +3885,16 @@
                           <a:solidFill>
                             <a:srgbClr val="244B3B"/>
                           </a:solidFill>
-                          <a:latin typeface="Aptos" pitchFamily="34" charset="0"/>
-                          <a:ea typeface="Aptos" pitchFamily="34" charset="-122"/>
-                          <a:cs typeface="Aptos" pitchFamily="34" charset="-120"/>
+                          <a:latin typeface="Arial" pitchFamily="34" charset="0"/>
+                          <a:ea typeface="Arial" pitchFamily="34" charset="-122"/>
+                          <a:cs typeface="Arial" pitchFamily="34" charset="-120"/>
                         </a:rPr>
                         <a:t>Prêmio total</a:t>
                       </a:r>
                       <a:endParaRPr lang="en-US" sz="2200" dirty="0">
-                        <a:latin typeface="Aptos" charset="0"/>
-                        <a:ea typeface="Aptos" charset="0"/>
-                        <a:cs typeface="Aptos" charset="0"/>
+                        <a:latin typeface="Arial" charset="0"/>
+                        <a:ea typeface="Arial" charset="0"/>
+                        <a:cs typeface="Arial" charset="0"/>
                       </a:endParaRPr>
                     </a:p>
                   </a:txBody>
@@ -3953,16 +3953,16 @@
                           <a:solidFill>
                             <a:srgbClr val="244B3B"/>
                           </a:solidFill>
-                          <a:latin typeface="Aptos" pitchFamily="34" charset="0"/>
-                          <a:ea typeface="Aptos" pitchFamily="34" charset="-122"/>
-                          <a:cs typeface="Aptos" pitchFamily="34" charset="-120"/>
+                          <a:latin typeface="Arial" pitchFamily="34" charset="0"/>
+                          <a:ea typeface="Arial" pitchFamily="34" charset="-122"/>
+                          <a:cs typeface="Arial" pitchFamily="34" charset="-120"/>
                         </a:rPr>
                         <a:t>R$ 32.500</a:t>
                       </a:r>
                       <a:endParaRPr lang="en-US" sz="2200" dirty="0">
-                        <a:latin typeface="Aptos" charset="0"/>
-                        <a:ea typeface="Aptos" charset="0"/>
-                        <a:cs typeface="Aptos" charset="0"/>
+                        <a:latin typeface="Arial" charset="0"/>
+                        <a:ea typeface="Arial" charset="0"/>
+                        <a:cs typeface="Arial" charset="0"/>
                       </a:endParaRPr>
                     </a:p>
                   </a:txBody>
@@ -4021,16 +4021,16 @@
                           <a:solidFill>
                             <a:srgbClr val="244B3B"/>
                           </a:solidFill>
-                          <a:latin typeface="Aptos" pitchFamily="34" charset="0"/>
-                          <a:ea typeface="Aptos" pitchFamily="34" charset="-122"/>
-                          <a:cs typeface="Aptos" pitchFamily="34" charset="-120"/>
+                          <a:latin typeface="Arial" pitchFamily="34" charset="0"/>
+                          <a:ea typeface="Arial" pitchFamily="34" charset="-122"/>
+                          <a:cs typeface="Arial" pitchFamily="34" charset="-120"/>
                         </a:rPr>
                         <a:t>R$ 41.800</a:t>
                       </a:r>
                       <a:endParaRPr lang="en-US" sz="2200" dirty="0">
-                        <a:latin typeface="Aptos" charset="0"/>
-                        <a:ea typeface="Aptos" charset="0"/>
-                        <a:cs typeface="Aptos" charset="0"/>
+                        <a:latin typeface="Arial" charset="0"/>
+                        <a:ea typeface="Arial" charset="0"/>
+                        <a:cs typeface="Arial" charset="0"/>
                       </a:endParaRPr>
                     </a:p>
                   </a:txBody>
@@ -4091,16 +4091,16 @@
                           <a:solidFill>
                             <a:srgbClr val="244B3B"/>
                           </a:solidFill>
-                          <a:latin typeface="Aptos" pitchFamily="34" charset="0"/>
-                          <a:ea typeface="Aptos" pitchFamily="34" charset="-122"/>
-                          <a:cs typeface="Aptos" pitchFamily="34" charset="-120"/>
+                          <a:latin typeface="Arial" pitchFamily="34" charset="0"/>
+                          <a:ea typeface="Arial" pitchFamily="34" charset="-122"/>
+                          <a:cs typeface="Arial" pitchFamily="34" charset="-120"/>
                         </a:rPr>
                         <a:t>Franquia Side B</a:t>
                       </a:r>
                       <a:endParaRPr lang="en-US" sz="2200" dirty="0">
-                        <a:latin typeface="Aptos" charset="0"/>
-                        <a:ea typeface="Aptos" charset="0"/>
-                        <a:cs typeface="Aptos" charset="0"/>
+                        <a:latin typeface="Arial" charset="0"/>
+                        <a:ea typeface="Arial" charset="0"/>
+                        <a:cs typeface="Arial" charset="0"/>
                       </a:endParaRPr>
                     </a:p>
                   </a:txBody>
@@ -4159,16 +4159,16 @@
                           <a:solidFill>
                             <a:srgbClr val="244B3B"/>
                           </a:solidFill>
-                          <a:latin typeface="Aptos" pitchFamily="34" charset="0"/>
-                          <a:ea typeface="Aptos" pitchFamily="34" charset="-122"/>
-                          <a:cs typeface="Aptos" pitchFamily="34" charset="-120"/>
+                          <a:latin typeface="Arial" pitchFamily="34" charset="0"/>
+                          <a:ea typeface="Arial" pitchFamily="34" charset="-122"/>
+                          <a:cs typeface="Arial" pitchFamily="34" charset="-120"/>
                         </a:rPr>
                         <a:t>R$ 50 mil</a:t>
                       </a:r>
                       <a:endParaRPr lang="en-US" sz="2200" dirty="0">
-                        <a:latin typeface="Aptos" charset="0"/>
-                        <a:ea typeface="Aptos" charset="0"/>
-                        <a:cs typeface="Aptos" charset="0"/>
+                        <a:latin typeface="Arial" charset="0"/>
+                        <a:ea typeface="Arial" charset="0"/>
+                        <a:cs typeface="Arial" charset="0"/>
                       </a:endParaRPr>
                     </a:p>
                   </a:txBody>
@@ -4227,16 +4227,16 @@
                           <a:solidFill>
                             <a:srgbClr val="244B3B"/>
                           </a:solidFill>
-                          <a:latin typeface="Aptos" pitchFamily="34" charset="0"/>
-                          <a:ea typeface="Aptos" pitchFamily="34" charset="-122"/>
-                          <a:cs typeface="Aptos" pitchFamily="34" charset="-120"/>
+                          <a:latin typeface="Arial" pitchFamily="34" charset="0"/>
+                          <a:ea typeface="Arial" pitchFamily="34" charset="-122"/>
+                          <a:cs typeface="Arial" pitchFamily="34" charset="-120"/>
                         </a:rPr>
                         <a:t>R$ 100 mil</a:t>
                       </a:r>
                       <a:endParaRPr lang="en-US" sz="2200" dirty="0">
-                        <a:latin typeface="Aptos" charset="0"/>
-                        <a:ea typeface="Aptos" charset="0"/>
-                        <a:cs typeface="Aptos" charset="0"/>
+                        <a:latin typeface="Arial" charset="0"/>
+                        <a:ea typeface="Arial" charset="0"/>
+                        <a:cs typeface="Arial" charset="0"/>
                       </a:endParaRPr>
                     </a:p>
                   </a:txBody>
@@ -4297,16 +4297,16 @@
                           <a:solidFill>
                             <a:srgbClr val="244B3B"/>
                           </a:solidFill>
-                          <a:latin typeface="Aptos" pitchFamily="34" charset="0"/>
-                          <a:ea typeface="Aptos" pitchFamily="34" charset="-122"/>
-                          <a:cs typeface="Aptos" pitchFamily="34" charset="-120"/>
+                          <a:latin typeface="Arial" pitchFamily="34" charset="0"/>
+                          <a:ea typeface="Arial" pitchFamily="34" charset="-122"/>
+                          <a:cs typeface="Arial" pitchFamily="34" charset="-120"/>
                         </a:rPr>
                         <a:t>Prazo complementar</a:t>
                       </a:r>
                       <a:endParaRPr lang="en-US" sz="2200" dirty="0">
-                        <a:latin typeface="Aptos" charset="0"/>
-                        <a:ea typeface="Aptos" charset="0"/>
-                        <a:cs typeface="Aptos" charset="0"/>
+                        <a:latin typeface="Arial" charset="0"/>
+                        <a:ea typeface="Arial" charset="0"/>
+                        <a:cs typeface="Arial" charset="0"/>
                       </a:endParaRPr>
                     </a:p>
                   </a:txBody>
@@ -4365,16 +4365,16 @@
                           <a:solidFill>
                             <a:srgbClr val="244B3B"/>
                           </a:solidFill>
-                          <a:latin typeface="Aptos" pitchFamily="34" charset="0"/>
-                          <a:ea typeface="Aptos" pitchFamily="34" charset="-122"/>
-                          <a:cs typeface="Aptos" pitchFamily="34" charset="-120"/>
+                          <a:latin typeface="Arial" pitchFamily="34" charset="0"/>
+                          <a:ea typeface="Arial" pitchFamily="34" charset="-122"/>
+                          <a:cs typeface="Arial" pitchFamily="34" charset="-120"/>
                         </a:rPr>
                         <a:t>12 meses</a:t>
                       </a:r>
                       <a:endParaRPr lang="en-US" sz="2200" dirty="0">
-                        <a:latin typeface="Aptos" charset="0"/>
-                        <a:ea typeface="Aptos" charset="0"/>
-                        <a:cs typeface="Aptos" charset="0"/>
+                        <a:latin typeface="Arial" charset="0"/>
+                        <a:ea typeface="Arial" charset="0"/>
+                        <a:cs typeface="Arial" charset="0"/>
                       </a:endParaRPr>
                     </a:p>
                   </a:txBody>
@@ -4433,16 +4433,16 @@
                           <a:solidFill>
                             <a:srgbClr val="244B3B"/>
                           </a:solidFill>
-                          <a:latin typeface="Aptos" pitchFamily="34" charset="0"/>
-                          <a:ea typeface="Aptos" pitchFamily="34" charset="-122"/>
-                          <a:cs typeface="Aptos" pitchFamily="34" charset="-120"/>
+                          <a:latin typeface="Arial" pitchFamily="34" charset="0"/>
+                          <a:ea typeface="Arial" pitchFamily="34" charset="-122"/>
+                          <a:cs typeface="Arial" pitchFamily="34" charset="-120"/>
                         </a:rPr>
                         <a:t>24 meses</a:t>
                       </a:r>
                       <a:endParaRPr lang="en-US" sz="2200" dirty="0">
-                        <a:latin typeface="Aptos" charset="0"/>
-                        <a:ea typeface="Aptos" charset="0"/>
-                        <a:cs typeface="Aptos" charset="0"/>
+                        <a:latin typeface="Arial" charset="0"/>
+                        <a:ea typeface="Arial" charset="0"/>
+                        <a:cs typeface="Arial" charset="0"/>
                       </a:endParaRPr>
                     </a:p>
                   </a:txBody>
@@ -4522,9 +4522,9 @@
                 <a:solidFill>
                   <a:srgbClr val="244B3B"/>
                 </a:solidFill>
-                <a:latin typeface="Aptos" pitchFamily="34" charset="0"/>
-                <a:ea typeface="Aptos" pitchFamily="34" charset="-122"/>
-                <a:cs typeface="Aptos" pitchFamily="34" charset="-120"/>
+                <a:latin typeface="Arial" pitchFamily="34" charset="0"/>
+                <a:ea typeface="Arial" pitchFamily="34" charset="-122"/>
+                <a:cs typeface="Arial" pitchFamily="34" charset="-120"/>
               </a:rPr>
               <a:t>10 diferenças textuais entre 16 critérios dos exemplos.</a:t>
             </a:r>
@@ -4561,9 +4561,9 @@
                 <a:solidFill>
                   <a:srgbClr val="66755D"/>
                 </a:solidFill>
-                <a:latin typeface="Aptos" pitchFamily="34" charset="0"/>
-                <a:ea typeface="Aptos" pitchFamily="34" charset="-122"/>
-                <a:cs typeface="Aptos" pitchFamily="34" charset="-120"/>
+                <a:latin typeface="Arial" pitchFamily="34" charset="0"/>
+                <a:ea typeface="Arial" pitchFamily="34" charset="-122"/>
+                <a:cs typeface="Arial" pitchFamily="34" charset="-120"/>
               </a:rPr>
               <a:t>Valores sintéticos. A comparação não recomenda uma contratação.</a:t>
             </a:r>
@@ -4632,9 +4632,9 @@
                 <a:solidFill>
                   <a:srgbClr val="244B3B"/>
                 </a:solidFill>
-                <a:latin typeface="Aptos Display" pitchFamily="34" charset="0"/>
-                <a:ea typeface="Aptos Display" pitchFamily="34" charset="-122"/>
-                <a:cs typeface="Aptos Display" pitchFamily="34" charset="-120"/>
+                <a:latin typeface="Arial" pitchFamily="34" charset="0"/>
+                <a:ea typeface="Arial" pitchFamily="34" charset="-122"/>
+                <a:cs typeface="Arial" pitchFamily="34" charset="-120"/>
               </a:rPr>
               <a:t>Validação e limitações</a:t>
             </a:r>
@@ -4671,9 +4671,9 @@
                 <a:solidFill>
                   <a:srgbClr val="66755D"/>
                 </a:solidFill>
-                <a:latin typeface="Aptos" pitchFamily="34" charset="0"/>
-                <a:ea typeface="Aptos" pitchFamily="34" charset="-122"/>
-                <a:cs typeface="Aptos" pitchFamily="34" charset="-120"/>
+                <a:latin typeface="Arial" pitchFamily="34" charset="0"/>
+                <a:ea typeface="Arial" pitchFamily="34" charset="-122"/>
+                <a:cs typeface="Arial" pitchFamily="34" charset="-120"/>
               </a:rPr>
               <a:t>InsurMinds / I2A2 2026</a:t>
             </a:r>
@@ -4710,9 +4710,9 @@
                 <a:solidFill>
                   <a:srgbClr val="66755D"/>
                 </a:solidFill>
-                <a:latin typeface="Aptos" pitchFamily="34" charset="0"/>
-                <a:ea typeface="Aptos" pitchFamily="34" charset="-122"/>
-                <a:cs typeface="Aptos" pitchFamily="34" charset="-120"/>
+                <a:latin typeface="Arial" pitchFamily="34" charset="0"/>
+                <a:ea typeface="Arial" pitchFamily="34" charset="-122"/>
+                <a:cs typeface="Arial" pitchFamily="34" charset="-120"/>
               </a:rPr>
               <a:t>07</a:t>
             </a:r>
@@ -4749,11 +4749,11 @@
                 <a:solidFill>
                   <a:srgbClr val="244B3B"/>
                 </a:solidFill>
-                <a:latin typeface="Aptos" pitchFamily="34" charset="0"/>
-                <a:ea typeface="Aptos" pitchFamily="34" charset="-122"/>
-                <a:cs typeface="Aptos" pitchFamily="34" charset="-120"/>
-              </a:rPr>
-              <a:t>18 testes automatizados</a:t>
+                <a:latin typeface="Arial" pitchFamily="34" charset="0"/>
+                <a:ea typeface="Arial" pitchFamily="34" charset="-122"/>
+                <a:cs typeface="Arial" pitchFamily="34" charset="-120"/>
+              </a:rPr>
+              <a:t>32 testes Python + 1 teste de upload</a:t>
             </a:r>
             <a:endParaRPr lang="en-US" sz="3200" dirty="0"/>
           </a:p>
@@ -4788,9 +4788,9 @@
                 <a:solidFill>
                   <a:srgbClr val="66755D"/>
                 </a:solidFill>
-                <a:latin typeface="Aptos" pitchFamily="34" charset="0"/>
-                <a:ea typeface="Aptos" pitchFamily="34" charset="-122"/>
-                <a:cs typeface="Aptos" pitchFamily="34" charset="-120"/>
+                <a:latin typeface="Arial" pitchFamily="34" charset="0"/>
+                <a:ea typeface="Arial" pitchFamily="34" charset="-122"/>
+                <a:cs typeface="Arial" pitchFamily="34" charset="-120"/>
               </a:rPr>
               <a:t>Leitura de documentos, evidências, persistência, comparação e exportações. Fluxo de interface verificado em desktop e celular.</a:t>
             </a:r>
@@ -4827,11 +4827,11 @@
                 <a:solidFill>
                   <a:srgbClr val="5D7C42"/>
                 </a:solidFill>
-                <a:latin typeface="Aptos" pitchFamily="34" charset="0"/>
-                <a:ea typeface="Aptos" pitchFamily="34" charset="-122"/>
-                <a:cs typeface="Aptos" pitchFamily="34" charset="-120"/>
-              </a:rPr>
-              <a:t>Validação funcional: extração real com Gemini em PDFs fictícios. Precisão em apólices de mercado ainda não avaliada.</a:t>
+                <a:latin typeface="Arial" pitchFamily="34" charset="0"/>
+                <a:ea typeface="Arial" pitchFamily="34" charset="-122"/>
+                <a:cs typeface="Arial" pitchFamily="34" charset="-120"/>
+              </a:rPr>
+              <a:t>Gemini 3.8: dois PDFs fictícios, 16 critérios verificados por documento e exportações PDF/JSON aprovadas.</a:t>
             </a:r>
             <a:endParaRPr lang="en-US" sz="2600" dirty="0"/>
           </a:p>
@@ -4866,9 +4866,9 @@
                 <a:solidFill>
                   <a:srgbClr val="66755D"/>
                 </a:solidFill>
-                <a:latin typeface="Aptos" pitchFamily="34" charset="0"/>
-                <a:ea typeface="Aptos" pitchFamily="34" charset="-122"/>
-                <a:cs typeface="Aptos" pitchFamily="34" charset="-120"/>
+                <a:latin typeface="Arial" pitchFamily="34" charset="0"/>
+                <a:ea typeface="Arial" pitchFamily="34" charset="-122"/>
+                <a:cs typeface="Arial" pitchFamily="34" charset="-120"/>
               </a:rPr>
               <a:t>A precisão em apólices reais ainda requer avaliação especializada.</a:t>
             </a:r>
@@ -4937,9 +4937,9 @@
                 <a:solidFill>
                   <a:srgbClr val="244B3B"/>
                 </a:solidFill>
-                <a:latin typeface="Aptos Display" pitchFamily="34" charset="0"/>
-                <a:ea typeface="Aptos Display" pitchFamily="34" charset="-122"/>
-                <a:cs typeface="Aptos Display" pitchFamily="34" charset="-120"/>
+                <a:latin typeface="Arial" pitchFamily="34" charset="0"/>
+                <a:ea typeface="Arial" pitchFamily="34" charset="-122"/>
+                <a:cs typeface="Arial" pitchFamily="34" charset="-120"/>
               </a:rPr>
               <a:t>Próximos passos da equipe</a:t>
             </a:r>
@@ -4976,9 +4976,9 @@
                 <a:solidFill>
                   <a:srgbClr val="66755D"/>
                 </a:solidFill>
-                <a:latin typeface="Aptos" pitchFamily="34" charset="0"/>
-                <a:ea typeface="Aptos" pitchFamily="34" charset="-122"/>
-                <a:cs typeface="Aptos" pitchFamily="34" charset="-120"/>
+                <a:latin typeface="Arial" pitchFamily="34" charset="0"/>
+                <a:ea typeface="Arial" pitchFamily="34" charset="-122"/>
+                <a:cs typeface="Arial" pitchFamily="34" charset="-120"/>
               </a:rPr>
               <a:t>InsurMinds / I2A2 2026</a:t>
             </a:r>
@@ -5015,9 +5015,9 @@
                 <a:solidFill>
                   <a:srgbClr val="66755D"/>
                 </a:solidFill>
-                <a:latin typeface="Aptos" pitchFamily="34" charset="0"/>
-                <a:ea typeface="Aptos" pitchFamily="34" charset="-122"/>
-                <a:cs typeface="Aptos" pitchFamily="34" charset="-120"/>
+                <a:latin typeface="Arial" pitchFamily="34" charset="0"/>
+                <a:ea typeface="Arial" pitchFamily="34" charset="-122"/>
+                <a:cs typeface="Arial" pitchFamily="34" charset="-120"/>
               </a:rPr>
               <a:t>08</a:t>
             </a:r>
@@ -5054,9 +5054,9 @@
                 <a:solidFill>
                   <a:srgbClr val="244B3B"/>
                 </a:solidFill>
-                <a:latin typeface="Aptos" pitchFamily="34" charset="0"/>
-                <a:ea typeface="Aptos" pitchFamily="34" charset="-122"/>
-                <a:cs typeface="Aptos" pitchFamily="34" charset="-120"/>
+                <a:latin typeface="Arial" pitchFamily="34" charset="0"/>
+                <a:ea typeface="Arial" pitchFamily="34" charset="-122"/>
+                <a:cs typeface="Arial" pitchFamily="34" charset="-120"/>
               </a:rPr>
               <a:t>Validação com documentos reais</a:t>
             </a:r>
@@ -5071,9 +5071,9 @@
                 <a:solidFill>
                   <a:srgbClr val="244B3B"/>
                 </a:solidFill>
-                <a:latin typeface="Aptos" pitchFamily="34" charset="0"/>
-                <a:ea typeface="Aptos" pitchFamily="34" charset="-122"/>
-                <a:cs typeface="Aptos" pitchFamily="34" charset="-120"/>
+                <a:latin typeface="Arial" pitchFamily="34" charset="0"/>
+                <a:ea typeface="Arial" pitchFamily="34" charset="-122"/>
+                <a:cs typeface="Arial" pitchFamily="34" charset="-120"/>
               </a:rPr>
               <a:t>e revisão por especialistas</a:t>
             </a:r>
@@ -5110,11 +5110,11 @@
                 <a:solidFill>
                   <a:srgbClr val="66755D"/>
                 </a:solidFill>
-                <a:latin typeface="Aptos" pitchFamily="34" charset="0"/>
-                <a:ea typeface="Aptos" pitchFamily="34" charset="-122"/>
-                <a:cs typeface="Aptos" pitchFamily="34" charset="-120"/>
-              </a:rPr>
-              <a:t>Evolução: múltiplas evidências por campo, comparação semântica, revisão versionada e fila persistente.</a:t>
+                <a:latin typeface="Arial" pitchFamily="34" charset="0"/>
+                <a:ea typeface="Arial" pitchFamily="34" charset="-122"/>
+                <a:cs typeface="Arial" pitchFamily="34" charset="-120"/>
+              </a:rPr>
+              <a:t>Evolução: avaliação por campo, comparação semântica, revisão versionada, autenticação e fila persistente.</a:t>
             </a:r>
             <a:endParaRPr lang="en-US" sz="2400" dirty="0"/>
           </a:p>
@@ -5149,9 +5149,9 @@
                 <a:solidFill>
                   <a:srgbClr val="5D7C42"/>
                 </a:solidFill>
-                <a:latin typeface="Aptos" pitchFamily="34" charset="0"/>
-                <a:ea typeface="Aptos" pitchFamily="34" charset="-122"/>
-                <a:cs typeface="Aptos" pitchFamily="34" charset="-120"/>
+                <a:latin typeface="Arial" pitchFamily="34" charset="0"/>
+                <a:ea typeface="Arial" pitchFamily="34" charset="-122"/>
+                <a:cs typeface="Arial" pitchFamily="34" charset="-120"/>
               </a:rPr>
               <a:t>Equipe: Victor Hugo Araujo, João Carlos Mendonça, Adriéli Zacharias e Bruno Veiga.</a:t>
             </a:r>
@@ -5166,9 +5166,9 @@
                 <a:solidFill>
                   <a:srgbClr val="5D7C42"/>
                 </a:solidFill>
-                <a:latin typeface="Aptos" pitchFamily="34" charset="0"/>
-                <a:ea typeface="Aptos" pitchFamily="34" charset="-122"/>
-                <a:cs typeface="Aptos" pitchFamily="34" charset="-120"/>
+                <a:latin typeface="Arial" pitchFamily="34" charset="0"/>
+                <a:ea typeface="Arial" pitchFamily="34" charset="-122"/>
+                <a:cs typeface="Arial" pitchFamily="34" charset="-120"/>
               </a:rPr>
               <a:t>Repositório público; avaliação especializada em apólices de mercado pendente.</a:t>
             </a:r>
@@ -5227,7 +5227,7 @@
     </a:clrScheme>
     <a:fontScheme name="Office">
       <a:majorFont>
-        <a:latin typeface="Aptos Display"/>
+        <a:latin typeface="Arial"/>
         <a:ea typeface=""/>
         <a:cs typeface=""/>
         <a:font script="Jpan" typeface="游ゴシック Light"/>
@@ -5279,7 +5279,7 @@
         <a:font script="Tfng" typeface="Ebrima"/>
       </a:majorFont>
       <a:minorFont>
-        <a:latin typeface="Aptos"/>
+        <a:latin typeface="Arial"/>
         <a:ea typeface=""/>
         <a:cs typeface=""/>
         <a:font script="Jpan" typeface="游ゴシック"/>

</xml_diff>

<commit_message>
chore: clean project scope and synchronize delivery materials
</commit_message>
<xml_diff>
--- a/Projeto_Final_Artefatos/InsurMinds_Projeto_Final.pptx
+++ b/Projeto_Final_Artefatos/InsurMinds_Projeto_Final.pptx
@@ -509,7 +509,7 @@
           <a:p>
             <a:r>
               <a:rPr lang="en-US" dirty="0"/>
-              <a:t>Enunciado do Projeto Final I2A2, fornecido pelo usuário, datado de 15/07/2026. Equipe InsurMinds: Victor Hugo Araujo, João Carlos Mendonça, Adriéli Zacharias e Bruno Veiga.</a:t>
+              <a:t>Projeto Final I2A2 2026. Equipe InsurMinds: Victor Hugo Araujo, João Carlos Mendonça, Adriéli Zacharias e Bruno Veiga.</a:t>
             </a:r>
             <a:endParaRPr lang="en-US" dirty="0"/>
           </a:p>
@@ -597,7 +597,7 @@
           <a:p>
             <a:r>
               <a:rPr lang="en-US" dirty="0"/>
-              <a:t>Contexto extraído do enunciado I2A2. Não se apresentam números de mercado ou alegações de tempo economizado.</a:t>
+              <a:t>Contexto da leitura documental de apólices D&amp;O. Não se apresentam números de mercado ou alegações de tempo economizado.</a:t>
             </a:r>
             <a:endParaRPr lang="en-US" dirty="0"/>
           </a:p>
@@ -1125,7 +1125,7 @@
           <a:p>
             <a:r>
               <a:rPr lang="en-US" dirty="0"/>
-              <a:t>Prazo informado no enunciado: 06/10/2026 às 23h59. Repositório público: https://github.com/vicTmm/i2a2-desafio-final. A equipe testou o fluxo com Gemini em documentos fictícios; a precisão em apólices de mercado ainda requer avaliação especializada.</a:t>
+              <a:t>Repositório público: https://github.com/vicTmm/i2a2-desafio-final. A equipe testou o fluxo com Gemini em documentos fictícios; a interpretação é conferida pelo usuário a partir das evidências.</a:t>
             </a:r>
             <a:endParaRPr lang="en-US" dirty="0"/>
           </a:p>
@@ -4870,7 +4870,7 @@
                 <a:ea typeface="Arial" pitchFamily="34" charset="-122"/>
                 <a:cs typeface="Arial" pitchFamily="34" charset="-120"/>
               </a:rPr>
-              <a:t>A precisão em apólices reais ainda requer avaliação especializada.</a:t>
+              <a:t>A interpretação é conferida pelo usuário a partir das evidências.</a:t>
             </a:r>
             <a:endParaRPr lang="en-US" sz="1800" dirty="0"/>
           </a:p>
@@ -4941,7 +4941,7 @@
                 <a:ea typeface="Arial" pitchFamily="34" charset="-122"/>
                 <a:cs typeface="Arial" pitchFamily="34" charset="-120"/>
               </a:rPr>
-              <a:t>Próximos passos da equipe</a:t>
+              <a:t>Entrega do projeto</a:t>
             </a:r>
             <a:endParaRPr lang="en-US" sz="3400" dirty="0"/>
           </a:p>
@@ -5058,7 +5058,7 @@
                 <a:ea typeface="Arial" pitchFamily="34" charset="-122"/>
                 <a:cs typeface="Arial" pitchFamily="34" charset="-120"/>
               </a:rPr>
-              <a:t>Validação com documentos reais</a:t>
+              <a:t>Leitura de PDFs com IA</a:t>
             </a:r>
             <a:endParaRPr lang="en-US" sz="3400" dirty="0"/>
           </a:p>
@@ -5075,7 +5075,7 @@
                 <a:ea typeface="Arial" pitchFamily="34" charset="-122"/>
                 <a:cs typeface="Arial" pitchFamily="34" charset="-120"/>
               </a:rPr>
-              <a:t>e revisão por especialistas</a:t>
+              <a:t>e comparação com evidências</a:t>
             </a:r>
             <a:endParaRPr lang="en-US" sz="3400" dirty="0"/>
           </a:p>
@@ -5114,7 +5114,7 @@
                 <a:ea typeface="Arial" pitchFamily="34" charset="-122"/>
                 <a:cs typeface="Arial" pitchFamily="34" charset="-120"/>
               </a:rPr>
-              <a:t>Evolução: avaliação por campo, comparação semântica, revisão versionada, autenticação e fila persistente.</a:t>
+              <a:t>Código-fonte, relatório técnico, System Design, apresentação, vídeo e PDFs fictícios disponíveis.</a:t>
             </a:r>
             <a:endParaRPr lang="en-US" sz="2400" dirty="0"/>
           </a:p>
@@ -5170,7 +5170,7 @@
                 <a:ea typeface="Arial" pitchFamily="34" charset="-122"/>
                 <a:cs typeface="Arial" pitchFamily="34" charset="-120"/>
               </a:rPr>
-              <a:t>Repositório público; avaliação especializada em apólices de mercado pendente.</a:t>
+              <a:t>Repositório: github.com/vicTmm/i2a2-desafio-final.</a:t>
             </a:r>
             <a:endParaRPr lang="en-US" sz="1600" dirty="0"/>
           </a:p>

</xml_diff>